<commit_message>
Changes made on all files
</commit_message>
<xml_diff>
--- a/MD3Assgn+Adhikari+R_NURS_6052.pptx
+++ b/MD3Assgn+Adhikari+R_NURS_6052.pptx
@@ -210,7 +210,7 @@
           <a:p>
             <a:fld id="{670D8687-4448-0B41-A841-4550392B7131}" type="datetimeFigureOut">
               <a:rPr lang="en-US" smtClean="0"/>
-              <a:t>6/15/23</a:t>
+              <a:t>8/7/25</a:t>
             </a:fld>
             <a:endParaRPr lang="en-US"/>
           </a:p>
@@ -1495,7 +1495,7 @@
           <a:p>
             <a:fld id="{AA70F276-1833-4A75-9C1D-A56E2295A68D}" type="datetimeFigureOut">
               <a:rPr lang="en-US" smtClean="0"/>
-              <a:t>6/15/23</a:t>
+              <a:t>8/7/25</a:t>
             </a:fld>
             <a:endParaRPr lang="en-US"/>
           </a:p>
@@ -1693,7 +1693,7 @@
           <a:p>
             <a:fld id="{AA70F276-1833-4A75-9C1D-A56E2295A68D}" type="datetimeFigureOut">
               <a:rPr lang="en-US" smtClean="0"/>
-              <a:t>6/15/23</a:t>
+              <a:t>8/7/25</a:t>
             </a:fld>
             <a:endParaRPr lang="en-US"/>
           </a:p>
@@ -1901,7 +1901,7 @@
           <a:p>
             <a:fld id="{AA70F276-1833-4A75-9C1D-A56E2295A68D}" type="datetimeFigureOut">
               <a:rPr lang="en-US" smtClean="0"/>
-              <a:t>6/15/23</a:t>
+              <a:t>8/7/25</a:t>
             </a:fld>
             <a:endParaRPr lang="en-US"/>
           </a:p>
@@ -2126,7 +2126,7 @@
           <a:p>
             <a:fld id="{AA70F276-1833-4A75-9C1D-A56E2295A68D}" type="datetimeFigureOut">
               <a:rPr lang="en-US" smtClean="0"/>
-              <a:t>6/15/23</a:t>
+              <a:t>8/7/25</a:t>
             </a:fld>
             <a:endParaRPr lang="en-US"/>
           </a:p>
@@ -2402,7 +2402,7 @@
           <a:p>
             <a:fld id="{AA70F276-1833-4A75-9C1D-A56E2295A68D}" type="datetimeFigureOut">
               <a:rPr lang="en-US" smtClean="0"/>
-              <a:t>6/15/23</a:t>
+              <a:t>8/7/25</a:t>
             </a:fld>
             <a:endParaRPr lang="en-US"/>
           </a:p>
@@ -2672,7 +2672,7 @@
           <a:p>
             <a:fld id="{AA70F276-1833-4A75-9C1D-A56E2295A68D}" type="datetimeFigureOut">
               <a:rPr lang="en-US" smtClean="0"/>
-              <a:t>6/15/23</a:t>
+              <a:t>8/7/25</a:t>
             </a:fld>
             <a:endParaRPr lang="en-US"/>
           </a:p>
@@ -3084,7 +3084,7 @@
           <a:p>
             <a:fld id="{AA70F276-1833-4A75-9C1D-A56E2295A68D}" type="datetimeFigureOut">
               <a:rPr lang="en-US" smtClean="0"/>
-              <a:t>6/15/23</a:t>
+              <a:t>8/7/25</a:t>
             </a:fld>
             <a:endParaRPr lang="en-US"/>
           </a:p>
@@ -3225,7 +3225,7 @@
           <a:p>
             <a:fld id="{AA70F276-1833-4A75-9C1D-A56E2295A68D}" type="datetimeFigureOut">
               <a:rPr lang="en-US" smtClean="0"/>
-              <a:t>6/15/23</a:t>
+              <a:t>8/7/25</a:t>
             </a:fld>
             <a:endParaRPr lang="en-US"/>
           </a:p>
@@ -3338,7 +3338,7 @@
           <a:p>
             <a:fld id="{AA70F276-1833-4A75-9C1D-A56E2295A68D}" type="datetimeFigureOut">
               <a:rPr lang="en-US" smtClean="0"/>
-              <a:t>6/15/23</a:t>
+              <a:t>8/7/25</a:t>
             </a:fld>
             <a:endParaRPr lang="en-US"/>
           </a:p>
@@ -3649,7 +3649,7 @@
           <a:p>
             <a:fld id="{AA70F276-1833-4A75-9C1D-A56E2295A68D}" type="datetimeFigureOut">
               <a:rPr lang="en-US" smtClean="0"/>
-              <a:t>6/15/23</a:t>
+              <a:t>8/7/25</a:t>
             </a:fld>
             <a:endParaRPr lang="en-US"/>
           </a:p>
@@ -3940,7 +3940,7 @@
           <a:p>
             <a:fld id="{AA70F276-1833-4A75-9C1D-A56E2295A68D}" type="datetimeFigureOut">
               <a:rPr lang="en-US" smtClean="0"/>
-              <a:t>6/15/23</a:t>
+              <a:t>8/7/25</a:t>
             </a:fld>
             <a:endParaRPr lang="en-US"/>
           </a:p>
@@ -4248,7 +4248,7 @@
             <a:fld id="{AA70F276-1833-4A75-9C1D-A56E2295A68D}" type="datetimeFigureOut">
               <a:rPr lang="en-US" smtClean="0"/>
               <a:pPr/>
-              <a:t>6/15/23</a:t>
+              <a:t>8/7/25</a:t>
             </a:fld>
             <a:endParaRPr lang="en-US" dirty="0"/>
           </a:p>
@@ -4748,7 +4748,14 @@
             </a:pPr>
             <a:r>
               <a:rPr lang="en-US" dirty="0"/>
-              <a:t>			Walden University</a:t>
+              <a:t>		</a:t>
+            </a:r>
+            <a:r>
+              <a:rPr lang="en-US" dirty="0">
+                <a:latin typeface="Times New Roman" panose="02020603050405020304" pitchFamily="18" charset="0"/>
+                <a:cs typeface="Times New Roman" panose="02020603050405020304" pitchFamily="18" charset="0"/>
+              </a:rPr>
+              <a:t>	Walden University</a:t>
             </a:r>
           </a:p>
           <a:p>
@@ -4756,21 +4763,33 @@
               <a:buNone/>
             </a:pPr>
             <a:r>
-              <a:rPr lang="en-US" dirty="0"/>
+              <a:rPr lang="en-US" dirty="0">
+                <a:latin typeface="Times New Roman" panose="02020603050405020304" pitchFamily="18" charset="0"/>
+                <a:cs typeface="Times New Roman" panose="02020603050405020304" pitchFamily="18" charset="0"/>
+              </a:rPr>
               <a:t>			Professor: Dr Linda S </a:t>
             </a:r>
             <a:r>
-              <a:rPr lang="en-US" dirty="0" err="1"/>
+              <a:rPr lang="en-US" dirty="0" err="1">
+                <a:latin typeface="Times New Roman" panose="02020603050405020304" pitchFamily="18" charset="0"/>
+                <a:cs typeface="Times New Roman" panose="02020603050405020304" pitchFamily="18" charset="0"/>
+              </a:rPr>
               <a:t>Johanson</a:t>
             </a:r>
-            <a:endParaRPr lang="en-US" dirty="0"/>
+            <a:endParaRPr lang="en-US" dirty="0">
+              <a:latin typeface="Times New Roman" panose="02020603050405020304" pitchFamily="18" charset="0"/>
+              <a:cs typeface="Times New Roman" panose="02020603050405020304" pitchFamily="18" charset="0"/>
+            </a:endParaRPr>
           </a:p>
           <a:p>
             <a:pPr marL="228600" indent="0">
               <a:buNone/>
             </a:pPr>
             <a:r>
-              <a:rPr lang="en-US" dirty="0"/>
+              <a:rPr lang="en-US" dirty="0">
+                <a:latin typeface="Times New Roman" panose="02020603050405020304" pitchFamily="18" charset="0"/>
+                <a:cs typeface="Times New Roman" panose="02020603050405020304" pitchFamily="18" charset="0"/>
+              </a:rPr>
               <a:t>			NRSE-(6052C-1/NURS-6052-1)</a:t>
             </a:r>
           </a:p>
@@ -4779,15 +4798,24 @@
               <a:buNone/>
             </a:pPr>
             <a:r>
-              <a:rPr lang="en-US" dirty="0"/>
+              <a:rPr lang="en-US" dirty="0">
+                <a:latin typeface="Times New Roman" panose="02020603050405020304" pitchFamily="18" charset="0"/>
+                <a:cs typeface="Times New Roman" panose="02020603050405020304" pitchFamily="18" charset="0"/>
+              </a:rPr>
               <a:t>			</a:t>
             </a:r>
             <a:r>
-              <a:rPr lang="en-US" dirty="0" err="1"/>
+              <a:rPr lang="en-US" dirty="0" err="1">
+                <a:latin typeface="Times New Roman" panose="02020603050405020304" pitchFamily="18" charset="0"/>
+                <a:cs typeface="Times New Roman" panose="02020603050405020304" pitchFamily="18" charset="0"/>
+              </a:rPr>
               <a:t>Ritu</a:t>
             </a:r>
             <a:r>
-              <a:rPr lang="en-US" dirty="0"/>
+              <a:rPr lang="en-US" dirty="0">
+                <a:latin typeface="Times New Roman" panose="02020603050405020304" pitchFamily="18" charset="0"/>
+                <a:cs typeface="Times New Roman" panose="02020603050405020304" pitchFamily="18" charset="0"/>
+              </a:rPr>
               <a:t> Adhikari</a:t>
             </a:r>
           </a:p>
@@ -4796,11 +4824,15 @@
               <a:buNone/>
             </a:pPr>
             <a:r>
-              <a:rPr lang="en-US" dirty="0"/>
+              <a:rPr lang="en-US" dirty="0">
+                <a:latin typeface="Times New Roman" panose="02020603050405020304" pitchFamily="18" charset="0"/>
+                <a:cs typeface="Times New Roman" panose="02020603050405020304" pitchFamily="18" charset="0"/>
+              </a:rPr>
               <a:t>			04/02/2023</a:t>
             </a:r>
           </a:p>
           <a:p>
+            <a:pPr algn="ctr"/>
             <a:endParaRPr lang="en-US" dirty="0"/>
           </a:p>
         </p:txBody>

</xml_diff>